<commit_message>
Record Midterm aggregate research artifacts
</commit_message>
<xml_diff>
--- a/outputs/midterm.pptx
+++ b/outputs/midterm.pptx
@@ -860,7 +860,7 @@
           <a:lstStyle/>
           <a:p>
             <a:r>
-              <a:t>4:40–5:50. Compare CV mean/SD and fixed-test metrics. SD is fold variation, not a confidence interval. Explain why majority prediction can have high F1. The CV-selected model (SVM) has holdout F1 0.901, compared with Dummy 0.897 (difference +0.004). This comparison is descriptive; no significance claim is made.</a:t>
+              <a:t>4:40–5:50. Compare CV mean/SD and fixed-test metrics. SD is fold variation, not a confidence interval. Explain why majority prediction can have high F1. SVM: holdout F1 0.901 vs Dummy 0.897 (gain +0.004); ROC-AUC 0.620. It detected 7/76 lower-rated apps. The F1 gain is descriptive; no statistical significance is claimed.</a:t>
             </a:r>
           </a:p>
         </p:txBody>
@@ -4465,7 +4465,7 @@
               </a:defRPr>
             </a:pPr>
             <a:r>
-              <a:t>132 prespecified keywords; up to 200 results/query</a:t>
+              <a:t>17 requests used; 132 keywords planned</a:t>
             </a:r>
           </a:p>
           <a:p>
@@ -4536,7 +4536,7 @@
               </a:defRPr>
             </a:pPr>
             <a:r>
-              <a:t>Promotional-content context • Raw JSON/descriptions excluded from publication</a:t>
+              <a:t>robots.txt disallows /search* • Raw JSON/descriptions stay private</a:t>
             </a:r>
           </a:p>
         </p:txBody>
@@ -5227,7 +5227,7 @@
         </p:nvGraphicFramePr>
         <p:xfrm>
           <a:off x="548640" y="1463040"/>
-          <a:ext cx="11811000" cy="2560320"/>
+          <a:ext cx="11064240" cy="2560320"/>
         </p:xfrm>
         <a:graphic>
           <a:graphicData uri="http://schemas.openxmlformats.org/drawingml/2006/table">
@@ -5236,12 +5236,12 @@
                 <a:tableStyleId>{5C22544A-7EE6-4342-B048-85BDC9FD1C3A}</a:tableStyleId>
               </a:tblPr>
               <a:tblGrid>
-                <a:gridCol w="1965960"/>
+                <a:gridCol w="2103120"/>
                 <a:gridCol w="2468880"/>
-                <a:gridCol w="1844040"/>
-                <a:gridCol w="1844040"/>
-                <a:gridCol w="1844040"/>
-                <a:gridCol w="1844040"/>
+                <a:gridCol w="1600200"/>
+                <a:gridCol w="1508760"/>
+                <a:gridCol w="1691640"/>
+                <a:gridCol w="1691640"/>
               </a:tblGrid>
               <a:tr h="512064">
                 <a:tc>
@@ -5741,7 +5741,7 @@
               </a:defRPr>
             </a:pPr>
             <a:r>
-              <a:t>The CV-selected model (SVM) has holdout F1 0.901, compared with Dummy 0.897 (difference +0.004). This comparison is descriptive; no significance claim is made.</a:t>
+              <a:t>SVM: holdout F1 0.901 vs Dummy 0.897 (gain +0.004); ROC-AUC 0.620. It detected 7/76 lower-rated apps. The F1 gain is descriptive; no statistical significance is claimed.</a:t>
             </a:r>
           </a:p>
         </p:txBody>
@@ -6041,7 +6041,7 @@
               </a:defRPr>
             </a:pPr>
             <a:r>
-              <a:t>Case 2 · FP · true 0, predicted 1</a:t>
+              <a:t>Case 4 · FN · true 1, predicted 0</a:t>
             </a:r>
           </a:p>
           <a:p>
@@ -6057,52 +6057,7 @@
               </a:defRPr>
             </a:pPr>
             <a:r>
-              <a:t>True rating is within 0.1 of the 4.5 boundary</a:t>
-            </a:r>
-          </a:p>
-          <a:p>
-            <a:pPr>
-              <a:spcAft>
-                <a:spcPts val="1400"/>
-              </a:spcAft>
-              <a:defRPr sz="2200" b="0">
-                <a:solidFill>
-                  <a:srgbClr val="102A43"/>
-                </a:solidFill>
-                <a:latin typeface="Aptos"/>
-              </a:defRPr>
-            </a:pPr>
-          </a:p>
-          <a:p>
-            <a:pPr>
-              <a:spcAft>
-                <a:spcPts val="1400"/>
-              </a:spcAft>
-              <a:defRPr sz="2200" b="0">
-                <a:solidFill>
-                  <a:srgbClr val="102A43"/>
-                </a:solidFill>
-                <a:latin typeface="Aptos"/>
-              </a:defRPr>
-            </a:pPr>
-            <a:r>
-              <a:t>Case 3 · FP · true 0, predicted 1</a:t>
-            </a:r>
-          </a:p>
-          <a:p>
-            <a:pPr>
-              <a:spcAft>
-                <a:spcPts val="1400"/>
-              </a:spcAft>
-              <a:defRPr sz="2200" b="0">
-                <a:solidFill>
-                  <a:srgbClr val="102A43"/>
-                </a:solidFill>
-                <a:latin typeface="Aptos"/>
-              </a:defRPr>
-            </a:pPr>
-            <a:r>
-              <a:t>True rating is within 0.1 of the 4.5 boundary</a:t>
+              <a:t>Metadata alone does not explain the observed rating</a:t>
             </a:r>
           </a:p>
         </p:txBody>
@@ -6276,7 +6231,7 @@
               </a:defRPr>
             </a:pPr>
             <a:r>
-              <a:t>The CV-selected model (SVM) has holdout F1 0.901, compared with Dummy 0.897 (difference +0.004). This comparison is descriptive; no significance claim is made.</a:t>
+              <a:t>SVM: holdout F1 0.901 vs Dummy 0.897 (gain +0.004); ROC-AUC 0.620. It detected 7/76 lower-rated apps. The F1 gain is descriptive; no statistical significance is claimed.</a:t>
             </a:r>
           </a:p>
         </p:txBody>

</xml_diff>